<commit_message>
Add final report and A3 poster; add TRIBE v2 training data and fMRI-vs-EEG slides to Review III
</commit_message>
<xml_diff>
--- a/deck/Review2_Sarkar_Choudhuri.pptx
+++ b/deck/Review2_Sarkar_Choudhuri.pptx
@@ -152,20 +152,20 @@
   <p:extLst>
     <p:ext uri="{521415D9-36F7-43E2-AB2F-B90AF26B5E84}">
       <p14:sectionLst xmlns:p14="http://schemas.microsoft.com/office/powerpoint/2010/main">
-        <p14:section name="Opening" id="{a9ded6be-1a9f-3adf-46e4-4040c3854854}">
+        <p14:section name="Opening" id="{c19a4672-1b4b-7ab2-772d-8dd2291f1294}">
           <p14:sldIdLst>
             <p14:sldId id="256"/>
             <p14:sldId id="257"/>
           </p14:sldIdLst>
         </p14:section>
-        <p14:section name="Problem" id="{44ce10b5-a344-f8e8-aa37-1b2d9a2a831a}">
+        <p14:section name="Problem" id="{aab29aba-5837-a949-0ccf-5ecf99c6995e}">
           <p14:sldIdLst>
             <p14:sldId id="258"/>
             <p14:sldId id="259"/>
             <p14:sldId id="260"/>
           </p14:sldIdLst>
         </p14:section>
-        <p14:section name="Literature" id="{f985b391-4ba8-ca25-06f8-58feddd5c182}">
+        <p14:section name="Literature" id="{54fe31f9-cc7e-bb21-410c-b433a5c80aa1}">
           <p14:sldIdLst>
             <p14:sldId id="261"/>
             <p14:sldId id="262"/>
@@ -179,7 +179,7 @@
             <p14:sldId id="270"/>
           </p14:sldIdLst>
         </p14:section>
-        <p14:section name="Method" id="{01de7081-5557-f7ae-4616-5a194376d050}">
+        <p14:section name="Method" id="{45dcd044-9c66-8e39-4d6d-3f7ddfb400e2}">
           <p14:sldIdLst>
             <p14:sldId id="271"/>
             <p14:sldId id="272"/>
@@ -189,7 +189,7 @@
             <p14:sldId id="276"/>
           </p14:sldIdLst>
         </p14:section>
-        <p14:section name="Results" id="{27396611-44c2-5cff-e826-c413c235fe7a}">
+        <p14:section name="Results" id="{b546ab90-522b-d0eb-207b-76d7a20a7123}">
           <p14:sldIdLst>
             <p14:sldId id="277"/>
             <p14:sldId id="278"/>
@@ -202,7 +202,7 @@
             <p14:sldId id="285"/>
           </p14:sldIdLst>
         </p14:section>
-        <p14:section name="Early results" id="{8e42d26c-275f-d4c6-aa25-34b181f4d986}">
+        <p14:section name="Early results" id="{65a05533-9cc8-0d2a-936d-be6b9c2a2a6c}">
           <p14:sldIdLst>
             <p14:sldId id="286"/>
             <p14:sldId id="287"/>
@@ -212,7 +212,7 @@
             <p14:sldId id="291"/>
           </p14:sldIdLst>
         </p14:section>
-        <p14:section name="Plan" id="{00e32916-7016-d90b-204f-e5514f4f5e9c}">
+        <p14:section name="Plan" id="{05f966cc-130e-d18b-ce8d-fabe3d3d8d83}">
           <p14:sldIdLst>
             <p14:sldId id="292"/>
             <p14:sldId id="293"/>
@@ -220,7 +220,7 @@
             <p14:sldId id="295"/>
           </p14:sldIdLst>
         </p14:section>
-        <p14:section name="Backup: anticipated questions" id="{7c982d53-c08b-3bbd-cfa7-d172c43ab352}">
+        <p14:section name="Backup: anticipated questions" id="{85ee93be-a4c7-7f6b-6d5d-e1a268bc22c1}">
           <p14:sldIdLst>
             <p14:sldId id="296"/>
             <p14:sldId id="297"/>
@@ -229,7 +229,7 @@
             <p14:sldId id="300"/>
           </p14:sldIdLst>
         </p14:section>
-        <p14:section name="References" id="{51456326-1a67-088e-cad7-28f09f61121d}">
+        <p14:section name="References" id="{c01cf780-fc28-dd66-7120-5b65c7100aa5}">
           <p14:sldIdLst>
             <p14:sldId id="301"/>
           </p14:sldIdLst>
@@ -4510,7 +4510,7 @@
           <a:p>
             <a:r>
               <a:rPr lang="en-US" dirty="0"/>
-              <a:t>Brain2Qwerty is the decisive reason we dropped EEG: even Meta, with 35 participants and a purpose-built architecture, gets 65% character error with EEG versus 29% with MEG. TRIBE v2's own paper frames it for in-silico neuroscience and lists decoders separately (Tang, Défossez); it never inverts itself. Weights and code are public (CC BY-NC 4.0), which makes our study possible.</a:t>
+              <a:t>Brain2Qwerty is the decisive reason we dropped EEG: even Meta, with 35 participants and a purpose-built architecture, gets 67% character error with EEG versus 32% with MEG. TRIBE v2's own paper frames it for in-silico neuroscience and lists decoders separately (Tang, Défossez); it never inverts itself. Weights and code are public (CC BY-NC 4.0), which makes our study possible.</a:t>
             </a:r>
             <a:endParaRPr lang="en-US" dirty="0"/>
           </a:p>
@@ -36283,7 +36283,7 @@
                 <a:ea typeface="Calibri" pitchFamily="34" charset="-122"/>
                 <a:cs typeface="Calibri" pitchFamily="34" charset="-120"/>
               </a:rPr>
-              <a:t>Brain2Qwerty (Nat. Neurosci. 2026): the same architecture reaches 29% character error with MEG but 65% with EEG. EEG lacks the spatial resolution to separate semantic regions.</a:t>
+              <a:t>Brain2Qwerty (Lévy et al., arXiv 2502.17480): the same architecture reaches 32% character error with MEG but 67% with EEG. EEG lacks the spatial resolution to separate semantic regions.</a:t>
             </a:r>
             <a:endParaRPr lang="en-US" sz="1600" dirty="0"/>
           </a:p>
@@ -38136,7 +38136,7 @@
                 <a:ea typeface="Calibri" pitchFamily="34" charset="-122"/>
                 <a:cs typeface="Calibri" pitchFamily="34" charset="-120"/>
               </a:rPr>
-              <a:t>[11] J. Lévy, M. Zhang, S. Pinet, J. Rapin, H. Banville, S. d’Ascoli, J.-R. King, “Noninvasive decoding of typed sentences from human brain activity,” Nat. Neurosci., 2026.</a:t>
+              <a:t>[11] J. Lévy, M. Zhang, S. Pinet, J. Rapin, H. Banville, S. d’Ascoli, J.-R. King, “Brain-to-text decoding: A non-invasive approach via typing,” arXiv:2502.17480, 2025.</a:t>
             </a:r>
             <a:endParaRPr lang="en-US" sz="1250" dirty="0"/>
           </a:p>
@@ -41913,7 +41913,7 @@
                           <a:ea typeface="Calibri" pitchFamily="34" charset="-122"/>
                           <a:cs typeface="Calibri" pitchFamily="34" charset="-120"/>
                         </a:rPr>
-                        <a:t>Lévy et al. (Brain2Qwerty), Nat. Neurosci. 2026 [11]</a:t>
+                        <a:t>Lévy et al. (Brain2Qwerty), arXiv 2025 [11]</a:t>
                       </a:r>
                       <a:endParaRPr lang="en-US" sz="1500" dirty="0">
                         <a:latin typeface="Calibri" charset="0"/>
@@ -41981,7 +41981,7 @@
                           <a:ea typeface="Calibri" pitchFamily="34" charset="-122"/>
                           <a:cs typeface="Calibri" pitchFamily="34" charset="-120"/>
                         </a:rPr>
-                        <a:t>Typed sentences decoded: CER 29% with MEG vs 65% with EEG</a:t>
+                        <a:t>Typed sentences decoded: CER 32% with MEG vs 67% with EEG</a:t>
                       </a:r>
                       <a:endParaRPr lang="en-US" sz="1500" dirty="0">
                         <a:latin typeface="Calibri" charset="0"/>

</xml_diff>